<commit_message>
Update team member names: Dilipan Y (PES1UG24AM092) and Sai Hemanth (PES1UG24AM101)
</commit_message>
<xml_diff>
--- a/Mini_Project_Presentation.pptx
+++ b/Mini_Project_Presentation.pptx
@@ -3313,7 +3313,7 @@
               <a:spcAft>
                 <a:spcPts val="600"/>
               </a:spcAft>
-              <a:defRPr sz="1500" b="1">
+              <a:defRPr sz="1400" b="1">
                 <a:solidFill>
                   <a:srgbClr val="BFDCE6"/>
                 </a:solidFill>
@@ -3321,7 +3321,7 @@
               </a:defRPr>
             </a:pPr>
             <a:r>
-              <a:t>Member 1 Pipeline: Data Engineering &amp; SMOTE</a:t>
+              <a:t>Dilipan Y (PES1UG24AM092) — Data Eng &amp; SMOTE</a:t>
             </a:r>
           </a:p>
           <a:p>
@@ -3419,7 +3419,7 @@
               <a:spcAft>
                 <a:spcPts val="600"/>
               </a:spcAft>
-              <a:defRPr sz="1500" b="1">
+              <a:defRPr sz="1400" b="1">
                 <a:solidFill>
                   <a:srgbClr val="BFDCE6"/>
                 </a:solidFill>
@@ -3427,7 +3427,7 @@
               </a:defRPr>
             </a:pPr>
             <a:r>
-              <a:t>Member 2 Pipeline: CoxPH &amp; Survival Analysis</a:t>
+              <a:t>Sai Hemanth (PES1UG24AM101) — CoxPH &amp; Survival</a:t>
             </a:r>
           </a:p>
           <a:p>
@@ -3701,7 +3701,7 @@
               <a:spcAft>
                 <a:spcPts val="800"/>
               </a:spcAft>
-              <a:defRPr sz="1400" b="1">
+              <a:defRPr sz="1350" b="1">
                 <a:solidFill>
                   <a:srgbClr val="BFDCE6"/>
                 </a:solidFill>
@@ -3709,7 +3709,7 @@
               </a:defRPr>
             </a:pPr>
             <a:r>
-              <a:t>Member 1 Work Split (Generative &amp; Augmentation)</a:t>
+              <a:t>Dilipan Y — PES1UG24AM092 (Generative &amp; SMOTE)</a:t>
             </a:r>
           </a:p>
           <a:p>
@@ -3839,7 +3839,7 @@
               <a:spcAft>
                 <a:spcPts val="800"/>
               </a:spcAft>
-              <a:defRPr sz="1400" b="1">
+              <a:defRPr sz="1350" b="1">
                 <a:solidFill>
                   <a:srgbClr val="BFDCE6"/>
                 </a:solidFill>
@@ -3847,7 +3847,7 @@
               </a:defRPr>
             </a:pPr>
             <a:r>
-              <a:t>Member 2 Work Split (Survival Regression &amp; Demo)</a:t>
+              <a:t>Sai Hemanth — PES1UG24AM101 (CoxPH &amp; Survival)</a:t>
             </a:r>
           </a:p>
           <a:p>
@@ -5185,7 +5185,7 @@
               </a:defRPr>
             </a:pPr>
             <a:r>
-              <a:t>Member 1 Pipeline: Objective data-driven threshold selection via Laplace Multinomial Naive Bayes</a:t>
+              <a:t>Presenter: Dilipan Y (PES1UG24AM092) | Objective threshold selection via Laplace Multinomial Naive Bayes</a:t>
             </a:r>
           </a:p>
         </p:txBody>
@@ -5627,7 +5627,7 @@
               </a:defRPr>
             </a:pPr>
             <a:r>
-              <a:t>Member 1 Pipeline: Populating the scarce high-risk (&lt; 270 days) Stage IIB and Stage III cohort</a:t>
+              <a:t>Presenter: Dilipan Y (PES1UG24AM092) | Populating the scarce high-risk (&lt; 270 days) Stage IIB and Stage III cohort</a:t>
             </a:r>
           </a:p>
         </p:txBody>
@@ -6069,7 +6069,7 @@
               </a:defRPr>
             </a:pPr>
             <a:r>
-              <a:t>Member 2 Pipeline: Removing collinear high-error-band (&gt; 1.0) features to stabilize Cox regression</a:t>
+              <a:t>Presenter: Sai Hemanth (PES1UG24AM101) | Removing collinear high-error-band (&gt; 1.0) features to stabilize Cox regression</a:t>
             </a:r>
           </a:p>
         </p:txBody>
@@ -6707,7 +6707,7 @@
               </a:defRPr>
             </a:pPr>
             <a:r>
-              <a:t>Member 2 Pipeline: 10-Fold CV Harrell's Concordance Index (C-Index) across Clinical, Radiomic &amp; Combined Sets</a:t>
+              <a:t>Presenter: Sai Hemanth (PES1UG24AM101) | 10-Fold CV Harrell's Concordance Index (C-Index) across Modalities</a:t>
             </a:r>
           </a:p>
         </p:txBody>
@@ -7165,7 +7165,7 @@
               </a:defRPr>
             </a:pPr>
             <a:r>
-              <a:t>Member 2 Pipeline: Quantifying feature impact via log Hazard Ratios (log(HR)) with 95% Confidence Intervals</a:t>
+              <a:t>Presenter: Sai Hemanth (PES1UG24AM101) | Quantifying feature impact via log Hazard Ratios with 95% CI</a:t>
             </a:r>
           </a:p>
         </p:txBody>

</xml_diff>